<commit_message>
Add gold-band slide with revised one-pager wording
Slide 3 reuses slide 2's layout with the shorter PROBLEM/FIX headings,
the new FIX bullets and the SCALABLE wording.

Co-Authored-By: Claude Opus 5.5 (1M context) <noreply@anthropic.com>
Claude-Session: https://claude.ai/code/session_01FkqX7FhXPG1DsbQcRetNgV
</commit_message>
<xml_diff>
--- a/docs/ANCHOR-one-pager.pptx
+++ b/docs/ANCHOR-one-pager.pptx
@@ -7,9 +7,10 @@
   <p:sldIdLst>
     <p:sldId id="256" r:id="rId2"/>
     <p:sldId id="257" r:id="rId3"/>
+    <p:sldId id="258" r:id="rId4"/>
   </p:sldIdLst>
   <p:notesMasterIdLst>
-    <p:notesMasterId r:id="rId4"/>
+    <p:notesMasterId r:id="rId5"/>
   </p:notesMasterIdLst>
   <p:sldSz cx="12192000" cy="6858000"/>
   <p:notesSz cx="6858000" cy="12192000"/>
@@ -615,6 +616,94 @@
             <a:fld id="{F7021451-1387-4CA6-816F-3879F97B5CBC}" type="slidenum">
               <a:rPr lang="en-US"/>
               <a:t>2</a:t>
+            </a:fld>
+            <a:endParaRPr lang="en-US"/>
+          </a:p>
+        </p:txBody>
+      </p:sp>
+    </p:spTree>
+    <p:extLst>
+      <p:ext uri="{BB962C8B-B14F-4D97-AF65-F5344CB8AC3E}">
+        <p14:creationId xmlns:p14="http://schemas.microsoft.com/office/powerpoint/2010/main" val="1024086991"/>
+      </p:ext>
+    </p:extLst>
+  </p:cSld>
+  <p:clrMapOvr>
+    <a:masterClrMapping/>
+  </p:clrMapOvr>
+</p:notes>
+</file>
+
+<file path=ppt/notesSlides/notesSlide3.xml><?xml version="1.0" encoding="utf-8"?>
+<p:notes xmlns:a="http://schemas.openxmlformats.org/drawingml/2006/main" xmlns:r="http://schemas.openxmlformats.org/officeDocument/2006/relationships" xmlns:p="http://schemas.openxmlformats.org/presentationml/2006/main">
+  <p:cSld>
+    <p:spTree>
+      <p:nvGrpSpPr>
+        <p:cNvPr id="1" name=""/>
+        <p:cNvGrpSpPr/>
+        <p:nvPr/>
+      </p:nvGrpSpPr>
+      <p:grpSpPr>
+        <a:xfrm>
+          <a:off x="0" y="0"/>
+          <a:ext cx="0" cy="0"/>
+          <a:chOff x="0" y="0"/>
+          <a:chExt cx="0" cy="0"/>
+        </a:xfrm>
+      </p:grpSpPr>
+      <p:sp>
+        <p:nvSpPr>
+          <p:cNvPr id="2" name="Slide Image Placeholder 1"/>
+          <p:cNvSpPr>
+            <a:spLocks noGrp="1" noRot="1" noChangeAspect="1"/>
+          </p:cNvSpPr>
+          <p:nvPr>
+            <p:ph type="sldImg"/>
+          </p:nvPr>
+        </p:nvSpPr>
+        <p:spPr/>
+      </p:sp>
+      <p:sp>
+        <p:nvSpPr>
+          <p:cNvPr id="3" name="Notes Placeholder 2"/>
+          <p:cNvSpPr>
+            <a:spLocks noGrp="1"/>
+          </p:cNvSpPr>
+          <p:nvPr>
+            <p:ph type="body" idx="1"/>
+          </p:nvPr>
+        </p:nvSpPr>
+        <p:spPr/>
+        <p:txBody>
+          <a:bodyPr/>
+          <a:lstStyle/>
+          <a:p>
+            <a:r>
+              <a:rPr lang="en-US" dirty="0"/>
+              <a:t/>
+            </a:r>
+            <a:endParaRPr lang="en-US" dirty="0"/>
+          </a:p>
+        </p:txBody>
+      </p:sp>
+      <p:sp>
+        <p:nvSpPr>
+          <p:cNvPr id="4" name="Slide Number Placeholder 3"/>
+          <p:cNvSpPr>
+            <a:spLocks noGrp="1"/>
+          </p:cNvSpPr>
+          <p:nvPr>
+            <p:ph type="sldNum" sz="quarter" idx="10"/>
+          </p:nvPr>
+        </p:nvSpPr>
+        <p:spPr/>
+        <p:txBody>
+          <a:bodyPr/>
+          <a:lstStyle/>
+          <a:p>
+            <a:fld id="{F7021451-1387-4CA6-816F-3879F97B5CBC}" type="slidenum">
+              <a:rPr lang="en-US"/>
+              <a:t>3</a:t>
             </a:fld>
             <a:endParaRPr lang="en-US"/>
           </a:p>
@@ -4895,6 +4984,1893 @@
 </p:sld>
 </file>
 
+<file path=ppt/slides/slide3.xml><?xml version="1.0" encoding="utf-8"?>
+<p:sld xmlns:a="http://schemas.openxmlformats.org/drawingml/2006/main" xmlns:r="http://schemas.openxmlformats.org/officeDocument/2006/relationships" xmlns:p="http://schemas.openxmlformats.org/presentationml/2006/main">
+  <p:cSld name="Slide 3">
+    <p:bg>
+      <p:bgPr>
+        <a:solidFill>
+          <a:srgbClr val="FFFFFF"/>
+        </a:solidFill>
+      </p:bgPr>
+    </p:bg>
+    <p:spTree>
+      <p:nvGrpSpPr>
+        <p:cNvPr id="1" name=""/>
+        <p:cNvGrpSpPr/>
+        <p:nvPr/>
+      </p:nvGrpSpPr>
+      <p:grpSpPr>
+        <a:xfrm>
+          <a:off x="0" y="0"/>
+          <a:ext cx="0" cy="0"/>
+          <a:chOff x="0" y="0"/>
+          <a:chExt cx="0" cy="0"/>
+        </a:xfrm>
+      </p:grpSpPr>
+      <p:sp>
+        <p:nvSpPr>
+          <p:cNvPr id="2" name="Header band"/>
+          <p:cNvSpPr/>
+          <p:nvPr/>
+        </p:nvSpPr>
+        <p:spPr>
+          <a:xfrm>
+            <a:off x="0" y="0"/>
+            <a:ext cx="12191695" cy="1328738"/>
+          </a:xfrm>
+          <a:prstGeom prst="rect">
+            <a:avLst/>
+          </a:prstGeom>
+          <a:solidFill>
+            <a:srgbClr val="0F2341"/>
+          </a:solidFill>
+          <a:ln w="12700">
+            <a:solidFill>
+              <a:srgbClr val="0F2341"/>
+            </a:solidFill>
+            <a:prstDash val="solid"/>
+          </a:ln>
+        </p:spPr>
+      </p:sp>
+      <p:sp>
+        <p:nvSpPr>
+          <p:cNvPr id="3" name="Logo ring"/>
+          <p:cNvSpPr/>
+          <p:nvPr/>
+        </p:nvSpPr>
+        <p:spPr>
+          <a:xfrm>
+            <a:off x="457189" y="305395"/>
+            <a:ext cx="876278" cy="876278"/>
+          </a:xfrm>
+          <a:prstGeom prst="ellipse">
+            <a:avLst/>
+          </a:prstGeom>
+          <a:solidFill>
+            <a:srgbClr val="0F2341"/>
+          </a:solidFill>
+          <a:ln w="12700">
+            <a:solidFill>
+              <a:srgbClr val="3D5070"/>
+            </a:solidFill>
+            <a:prstDash val="solid"/>
+          </a:ln>
+        </p:spPr>
+      </p:sp>
+      <p:pic>
+        <p:nvPicPr>
+          <p:cNvPr id="4" name="Anchor logo" descr="Anchor logo">    </p:cNvPr>
+          <p:cNvPicPr>
+            <a:picLocks noChangeAspect="1"/>
+          </p:cNvPicPr>
+          <p:nvPr/>
+        </p:nvPicPr>
+        <p:blipFill>
+          <a:blip r:embed="rId1"/>
+          <a:stretch>
+            <a:fillRect/>
+          </a:stretch>
+        </p:blipFill>
+        <p:spPr>
+          <a:xfrm>
+            <a:off x="609585" y="407194"/>
+            <a:ext cx="571486" cy="571486"/>
+          </a:xfrm>
+          <a:prstGeom prst="rect">
+            <a:avLst/>
+          </a:prstGeom>
+        </p:spPr>
+      </p:pic>
+      <p:sp>
+        <p:nvSpPr>
+          <p:cNvPr id="5" name="Title"/>
+          <p:cNvSpPr txBox="1"/>
+          <p:nvPr/>
+        </p:nvSpPr>
+        <p:spPr>
+          <a:xfrm>
+            <a:off x="1473163" y="160734"/>
+            <a:ext cx="4063898" cy="669727"/>
+          </a:xfrm>
+          <a:prstGeom prst="rect">
+            <a:avLst/>
+          </a:prstGeom>
+          <a:noFill/>
+          <a:ln/>
+        </p:spPr>
+        <p:txBody>
+          <a:bodyPr wrap="square" lIns="0" tIns="0" rIns="0" bIns="0" rtlCol="0" anchor="ctr"/>
+          <a:lstStyle/>
+          <a:p>
+            <a:pPr indent="0" marL="0">
+              <a:buNone/>
+            </a:pPr>
+            <a:r>
+              <a:rPr lang="en-US" sz="6000" b="1" dirty="0">
+                <a:solidFill>
+                  <a:srgbClr val="FFFFFF"/>
+                </a:solidFill>
+                <a:latin typeface="Arial" pitchFamily="34" charset="0"/>
+                <a:ea typeface="Arial" pitchFamily="34" charset="-122"/>
+                <a:cs typeface="Arial" pitchFamily="34" charset="-120"/>
+              </a:rPr>
+              <a:t>ANCHOR</a:t>
+            </a:r>
+            <a:endParaRPr lang="en-US" sz="6000" dirty="0"/>
+          </a:p>
+        </p:txBody>
+      </p:sp>
+      <p:sp>
+        <p:nvSpPr>
+          <p:cNvPr id="6" name="Subtitle"/>
+          <p:cNvSpPr txBox="1"/>
+          <p:nvPr/>
+        </p:nvSpPr>
+        <p:spPr>
+          <a:xfrm>
+            <a:off x="1504912" y="910828"/>
+            <a:ext cx="7302317" cy="225028"/>
+          </a:xfrm>
+          <a:prstGeom prst="rect">
+            <a:avLst/>
+          </a:prstGeom>
+          <a:noFill/>
+          <a:ln/>
+        </p:spPr>
+        <p:txBody>
+          <a:bodyPr wrap="square" lIns="0" tIns="0" rIns="0" bIns="0" rtlCol="0" anchor="ctr"/>
+          <a:lstStyle/>
+          <a:p>
+            <a:pPr indent="0" marL="0">
+              <a:buNone/>
+            </a:pPr>
+            <a:r>
+              <a:rPr lang="en-US" sz="1300" b="1" spc="100" kern="0" dirty="0">
+                <a:solidFill>
+                  <a:srgbClr val="FFFFFF"/>
+                </a:solidFill>
+                <a:latin typeface="Arial" pitchFamily="34" charset="0"/>
+                <a:ea typeface="Arial" pitchFamily="34" charset="-122"/>
+                <a:cs typeface="Arial" pitchFamily="34" charset="-120"/>
+              </a:rPr>
+              <a:t>AUTHORITATIVE NAVAL COMMUNICATIONS HUB FOR OFFICIAL RECORDS</a:t>
+            </a:r>
+            <a:endParaRPr lang="en-US" sz="1300" dirty="0"/>
+          </a:p>
+        </p:txBody>
+      </p:sp>
+      <p:sp>
+        <p:nvSpPr>
+          <p:cNvPr id="7" name="Tagline"/>
+          <p:cNvSpPr txBox="1"/>
+          <p:nvPr/>
+        </p:nvSpPr>
+        <p:spPr>
+          <a:xfrm>
+            <a:off x="8826279" y="385763"/>
+            <a:ext cx="3047924" cy="535781"/>
+          </a:xfrm>
+          <a:prstGeom prst="rect">
+            <a:avLst/>
+          </a:prstGeom>
+          <a:noFill/>
+          <a:ln/>
+        </p:spPr>
+        <p:txBody>
+          <a:bodyPr wrap="square" lIns="0" tIns="0" rIns="0" bIns="0" rtlCol="0" anchor="ctr"/>
+          <a:lstStyle/>
+          <a:p>
+            <a:pPr algn="ctr" indent="0" marL="0">
+              <a:lnSpc>
+                <a:spcPct val="95000"/>
+              </a:lnSpc>
+              <a:buNone/>
+            </a:pPr>
+            <a:r>
+              <a:rPr lang="en-US" sz="1900" b="1" dirty="0">
+                <a:solidFill>
+                  <a:srgbClr val="D2A96C"/>
+                </a:solidFill>
+                <a:latin typeface="Arial" pitchFamily="34" charset="0"/>
+                <a:ea typeface="Arial" pitchFamily="34" charset="-122"/>
+                <a:cs typeface="Arial" pitchFamily="34" charset="-120"/>
+              </a:rPr>
+              <a:t>THE ANCHOR THAT WILL</a:t>
+            </a:r>
+            <a:endParaRPr lang="en-US" sz="1900" dirty="0"/>
+          </a:p>
+          <a:p>
+            <a:pPr algn="ctr" indent="0" marL="0">
+              <a:lnSpc>
+                <a:spcPct val="95000"/>
+              </a:lnSpc>
+              <a:buNone/>
+            </a:pPr>
+            <a:r>
+              <a:rPr lang="en-US" sz="1900" b="1" dirty="0">
+                <a:solidFill>
+                  <a:srgbClr val="D2A96C"/>
+                </a:solidFill>
+                <a:latin typeface="Arial" pitchFamily="34" charset="0"/>
+                <a:ea typeface="Arial" pitchFamily="34" charset="-122"/>
+                <a:cs typeface="Arial" pitchFamily="34" charset="-120"/>
+              </a:rPr>
+              <a:t>NOT SLOW YOU DOWN</a:t>
+            </a:r>
+            <a:endParaRPr lang="en-US" sz="1900" dirty="0"/>
+          </a:p>
+        </p:txBody>
+      </p:sp>
+      <p:sp>
+        <p:nvSpPr>
+          <p:cNvPr id="8" name="Problem background"/>
+          <p:cNvSpPr/>
+          <p:nvPr/>
+        </p:nvSpPr>
+        <p:spPr>
+          <a:xfrm>
+            <a:off x="0" y="1328738"/>
+            <a:ext cx="6095848" cy="3412927"/>
+          </a:xfrm>
+          <a:prstGeom prst="rect">
+            <a:avLst/>
+          </a:prstGeom>
+          <a:solidFill>
+            <a:srgbClr val="F1F3F7"/>
+          </a:solidFill>
+          <a:ln w="12700">
+            <a:solidFill>
+              <a:srgbClr val="F1F3F7"/>
+            </a:solidFill>
+            <a:prstDash val="solid"/>
+          </a:ln>
+        </p:spPr>
+      </p:sp>
+      <p:sp>
+        <p:nvSpPr>
+          <p:cNvPr id="9" name="Shape 6"/>
+          <p:cNvSpPr/>
+          <p:nvPr/>
+        </p:nvSpPr>
+        <p:spPr>
+          <a:xfrm>
+            <a:off x="6083148" y="1543050"/>
+            <a:ext cx="0" cy="3000375"/>
+          </a:xfrm>
+          <a:prstGeom prst="line">
+            <a:avLst/>
+          </a:prstGeom>
+          <a:noFill/>
+          <a:ln w="19050">
+            <a:solidFill>
+              <a:srgbClr val="C9A26B"/>
+            </a:solidFill>
+            <a:prstDash val="solid"/>
+          </a:ln>
+        </p:spPr>
+      </p:sp>
+      <p:pic>
+        <p:nvPicPr>
+          <p:cNvPr id="10" name="Problem icon" descr="Problem icon">    </p:cNvPr>
+          <p:cNvPicPr>
+            <a:picLocks noChangeAspect="1"/>
+          </p:cNvPicPr>
+          <p:nvPr/>
+        </p:nvPicPr>
+        <p:blipFill>
+          <a:blip r:embed="rId2"/>
+          <a:stretch>
+            <a:fillRect/>
+          </a:stretch>
+        </p:blipFill>
+        <p:spPr>
+          <a:xfrm>
+            <a:off x="685783" y="1639491"/>
+            <a:ext cx="406390" cy="406390"/>
+          </a:xfrm>
+          <a:prstGeom prst="rect">
+            <a:avLst/>
+          </a:prstGeom>
+        </p:spPr>
+      </p:pic>
+      <p:sp>
+        <p:nvSpPr>
+          <p:cNvPr id="11" name="Problem heading"/>
+          <p:cNvSpPr txBox="1"/>
+          <p:nvPr/>
+        </p:nvSpPr>
+        <p:spPr>
+          <a:xfrm>
+            <a:off x="1219170" y="1526977"/>
+            <a:ext cx="4698883" cy="589359"/>
+          </a:xfrm>
+          <a:prstGeom prst="rect">
+            <a:avLst/>
+          </a:prstGeom>
+          <a:noFill/>
+          <a:ln/>
+        </p:spPr>
+        <p:txBody>
+          <a:bodyPr wrap="square" lIns="0" tIns="0" rIns="0" bIns="0" rtlCol="0" anchor="ctr"/>
+          <a:lstStyle/>
+          <a:p>
+            <a:pPr indent="0" marL="0">
+              <a:buNone/>
+            </a:pPr>
+            <a:r>
+              <a:rPr lang="en-US" sz="4200" b="1" dirty="0">
+                <a:solidFill>
+                  <a:srgbClr val="0F2341"/>
+                </a:solidFill>
+                <a:latin typeface="Arial" pitchFamily="34" charset="0"/>
+                <a:ea typeface="Arial" pitchFamily="34" charset="-122"/>
+                <a:cs typeface="Arial" pitchFamily="34" charset="-120"/>
+              </a:rPr>
+              <a:t>PROBLEM:</a:t>
+            </a:r>
+            <a:endParaRPr lang="en-US" sz="4200" dirty="0"/>
+          </a:p>
+        </p:txBody>
+      </p:sp>
+      <p:sp>
+        <p:nvSpPr>
+          <p:cNvPr id="12" name="Bullet dot"/>
+          <p:cNvSpPr/>
+          <p:nvPr/>
+        </p:nvSpPr>
+        <p:spPr>
+          <a:xfrm>
+            <a:off x="527037" y="2293144"/>
+            <a:ext cx="88898" cy="88898"/>
+          </a:xfrm>
+          <a:prstGeom prst="ellipse">
+            <a:avLst/>
+          </a:prstGeom>
+          <a:solidFill>
+            <a:srgbClr val="C9A26B"/>
+          </a:solidFill>
+          <a:ln w="12700">
+            <a:solidFill>
+              <a:srgbClr val="C9A26B"/>
+            </a:solidFill>
+            <a:prstDash val="solid"/>
+          </a:ln>
+        </p:spPr>
+      </p:sp>
+      <p:pic>
+        <p:nvPicPr>
+          <p:cNvPr id="13" name="Problem item icon" descr="Problem item icon">    </p:cNvPr>
+          <p:cNvPicPr>
+            <a:picLocks noChangeAspect="1"/>
+          </p:cNvPicPr>
+          <p:nvPr/>
+        </p:nvPicPr>
+        <p:blipFill>
+          <a:blip r:embed="rId3"/>
+          <a:stretch>
+            <a:fillRect/>
+          </a:stretch>
+        </p:blipFill>
+        <p:spPr>
+          <a:xfrm>
+            <a:off x="723882" y="2171902"/>
+            <a:ext cx="317492" cy="317492"/>
+          </a:xfrm>
+          <a:prstGeom prst="rect">
+            <a:avLst/>
+          </a:prstGeom>
+        </p:spPr>
+      </p:pic>
+      <p:sp>
+        <p:nvSpPr>
+          <p:cNvPr id="14" name="Problem item"/>
+          <p:cNvSpPr txBox="1"/>
+          <p:nvPr/>
+        </p:nvSpPr>
+        <p:spPr>
+          <a:xfrm>
+            <a:off x="1257269" y="2191345"/>
+            <a:ext cx="4762381" cy="278606"/>
+          </a:xfrm>
+          <a:prstGeom prst="rect">
+            <a:avLst/>
+          </a:prstGeom>
+          <a:noFill/>
+          <a:ln/>
+        </p:spPr>
+        <p:txBody>
+          <a:bodyPr wrap="square" lIns="0" tIns="0" rIns="0" bIns="0" rtlCol="0" anchor="ctr"/>
+          <a:lstStyle/>
+          <a:p>
+            <a:pPr indent="0" marL="0">
+              <a:buNone/>
+            </a:pPr>
+            <a:r>
+              <a:rPr lang="en-US" sz="1700" dirty="0">
+                <a:solidFill>
+                  <a:srgbClr val="13233F"/>
+                </a:solidFill>
+                <a:latin typeface="Arial" pitchFamily="34" charset="0"/>
+                <a:ea typeface="Arial" pitchFamily="34" charset="-122"/>
+                <a:cs typeface="Arial" pitchFamily="34" charset="-120"/>
+              </a:rPr>
+              <a:t>Inbox flooded with thousands of emails</a:t>
+            </a:r>
+            <a:endParaRPr lang="en-US" sz="1700" dirty="0"/>
+          </a:p>
+        </p:txBody>
+      </p:sp>
+      <p:sp>
+        <p:nvSpPr>
+          <p:cNvPr id="15" name="Bullet dot"/>
+          <p:cNvSpPr/>
+          <p:nvPr/>
+        </p:nvSpPr>
+        <p:spPr>
+          <a:xfrm>
+            <a:off x="527037" y="2694980"/>
+            <a:ext cx="88898" cy="88898"/>
+          </a:xfrm>
+          <a:prstGeom prst="ellipse">
+            <a:avLst/>
+          </a:prstGeom>
+          <a:solidFill>
+            <a:srgbClr val="C9A26B"/>
+          </a:solidFill>
+          <a:ln w="12700">
+            <a:solidFill>
+              <a:srgbClr val="C9A26B"/>
+            </a:solidFill>
+            <a:prstDash val="solid"/>
+          </a:ln>
+        </p:spPr>
+      </p:sp>
+      <p:pic>
+        <p:nvPicPr>
+          <p:cNvPr id="16" name="Problem item icon" descr="Problem item icon">    </p:cNvPr>
+          <p:cNvPicPr>
+            <a:picLocks noChangeAspect="1"/>
+          </p:cNvPicPr>
+          <p:nvPr/>
+        </p:nvPicPr>
+        <p:blipFill>
+          <a:blip r:embed="rId4"/>
+          <a:stretch>
+            <a:fillRect/>
+          </a:stretch>
+        </p:blipFill>
+        <p:spPr>
+          <a:xfrm>
+            <a:off x="723882" y="2573738"/>
+            <a:ext cx="317492" cy="317492"/>
+          </a:xfrm>
+          <a:prstGeom prst="rect">
+            <a:avLst/>
+          </a:prstGeom>
+        </p:spPr>
+      </p:pic>
+      <p:sp>
+        <p:nvSpPr>
+          <p:cNvPr id="17" name="Problem item"/>
+          <p:cNvSpPr txBox="1"/>
+          <p:nvPr/>
+        </p:nvSpPr>
+        <p:spPr>
+          <a:xfrm>
+            <a:off x="1257269" y="2593181"/>
+            <a:ext cx="4762381" cy="278606"/>
+          </a:xfrm>
+          <a:prstGeom prst="rect">
+            <a:avLst/>
+          </a:prstGeom>
+          <a:noFill/>
+          <a:ln/>
+        </p:spPr>
+        <p:txBody>
+          <a:bodyPr wrap="square" lIns="0" tIns="0" rIns="0" bIns="0" rtlCol="0" anchor="ctr"/>
+          <a:lstStyle/>
+          <a:p>
+            <a:pPr indent="0" marL="0">
+              <a:buNone/>
+            </a:pPr>
+            <a:r>
+              <a:rPr lang="en-US" sz="1700" dirty="0">
+                <a:solidFill>
+                  <a:srgbClr val="13233F"/>
+                </a:solidFill>
+                <a:latin typeface="Arial" pitchFamily="34" charset="0"/>
+                <a:ea typeface="Arial" pitchFamily="34" charset="-122"/>
+                <a:cs typeface="Arial" pitchFamily="34" charset="-120"/>
+              </a:rPr>
+              <a:t>Duplicate copies everywhere — no single truth</a:t>
+            </a:r>
+            <a:endParaRPr lang="en-US" sz="1700" dirty="0"/>
+          </a:p>
+        </p:txBody>
+      </p:sp>
+      <p:sp>
+        <p:nvSpPr>
+          <p:cNvPr id="18" name="Bullet dot"/>
+          <p:cNvSpPr/>
+          <p:nvPr/>
+        </p:nvSpPr>
+        <p:spPr>
+          <a:xfrm>
+            <a:off x="527037" y="3096816"/>
+            <a:ext cx="88898" cy="88898"/>
+          </a:xfrm>
+          <a:prstGeom prst="ellipse">
+            <a:avLst/>
+          </a:prstGeom>
+          <a:solidFill>
+            <a:srgbClr val="C9A26B"/>
+          </a:solidFill>
+          <a:ln w="12700">
+            <a:solidFill>
+              <a:srgbClr val="C9A26B"/>
+            </a:solidFill>
+            <a:prstDash val="solid"/>
+          </a:ln>
+        </p:spPr>
+      </p:sp>
+      <p:pic>
+        <p:nvPicPr>
+          <p:cNvPr id="19" name="Problem item icon" descr="Problem item icon">    </p:cNvPr>
+          <p:cNvPicPr>
+            <a:picLocks noChangeAspect="1"/>
+          </p:cNvPicPr>
+          <p:nvPr/>
+        </p:nvPicPr>
+        <p:blipFill>
+          <a:blip r:embed="rId5"/>
+          <a:stretch>
+            <a:fillRect/>
+          </a:stretch>
+        </p:blipFill>
+        <p:spPr>
+          <a:xfrm>
+            <a:off x="723882" y="2975574"/>
+            <a:ext cx="317492" cy="317492"/>
+          </a:xfrm>
+          <a:prstGeom prst="rect">
+            <a:avLst/>
+          </a:prstGeom>
+        </p:spPr>
+      </p:pic>
+      <p:sp>
+        <p:nvSpPr>
+          <p:cNvPr id="20" name="Problem item"/>
+          <p:cNvSpPr txBox="1"/>
+          <p:nvPr/>
+        </p:nvSpPr>
+        <p:spPr>
+          <a:xfrm>
+            <a:off x="1257269" y="2995017"/>
+            <a:ext cx="4762381" cy="278606"/>
+          </a:xfrm>
+          <a:prstGeom prst="rect">
+            <a:avLst/>
+          </a:prstGeom>
+          <a:noFill/>
+          <a:ln/>
+        </p:spPr>
+        <p:txBody>
+          <a:bodyPr wrap="square" lIns="0" tIns="0" rIns="0" bIns="0" rtlCol="0" anchor="ctr"/>
+          <a:lstStyle/>
+          <a:p>
+            <a:pPr indent="0" marL="0">
+              <a:buNone/>
+            </a:pPr>
+            <a:r>
+              <a:rPr lang="en-US" sz="1700" dirty="0">
+                <a:solidFill>
+                  <a:srgbClr val="13233F"/>
+                </a:solidFill>
+                <a:latin typeface="Arial" pitchFamily="34" charset="0"/>
+                <a:ea typeface="Arial" pitchFamily="34" charset="-122"/>
+                <a:cs typeface="Arial" pitchFamily="34" charset="-120"/>
+              </a:rPr>
+              <a:t>Manual sorting and filtering eats the day</a:t>
+            </a:r>
+            <a:endParaRPr lang="en-US" sz="1700" dirty="0"/>
+          </a:p>
+        </p:txBody>
+      </p:sp>
+      <p:sp>
+        <p:nvSpPr>
+          <p:cNvPr id="21" name="Bullet dot"/>
+          <p:cNvSpPr/>
+          <p:nvPr/>
+        </p:nvSpPr>
+        <p:spPr>
+          <a:xfrm>
+            <a:off x="527037" y="3498652"/>
+            <a:ext cx="88898" cy="88898"/>
+          </a:xfrm>
+          <a:prstGeom prst="ellipse">
+            <a:avLst/>
+          </a:prstGeom>
+          <a:solidFill>
+            <a:srgbClr val="C9A26B"/>
+          </a:solidFill>
+          <a:ln w="12700">
+            <a:solidFill>
+              <a:srgbClr val="C9A26B"/>
+            </a:solidFill>
+            <a:prstDash val="solid"/>
+          </a:ln>
+        </p:spPr>
+      </p:sp>
+      <p:pic>
+        <p:nvPicPr>
+          <p:cNvPr id="22" name="Problem item icon" descr="Problem item icon">    </p:cNvPr>
+          <p:cNvPicPr>
+            <a:picLocks noChangeAspect="1"/>
+          </p:cNvPicPr>
+          <p:nvPr/>
+        </p:nvPicPr>
+        <p:blipFill>
+          <a:blip r:embed="rId6"/>
+          <a:stretch>
+            <a:fillRect/>
+          </a:stretch>
+        </p:blipFill>
+        <p:spPr>
+          <a:xfrm>
+            <a:off x="723882" y="3377410"/>
+            <a:ext cx="317492" cy="317492"/>
+          </a:xfrm>
+          <a:prstGeom prst="rect">
+            <a:avLst/>
+          </a:prstGeom>
+        </p:spPr>
+      </p:pic>
+      <p:sp>
+        <p:nvSpPr>
+          <p:cNvPr id="23" name="Problem item"/>
+          <p:cNvSpPr txBox="1"/>
+          <p:nvPr/>
+        </p:nvSpPr>
+        <p:spPr>
+          <a:xfrm>
+            <a:off x="1257269" y="3396853"/>
+            <a:ext cx="4762381" cy="278606"/>
+          </a:xfrm>
+          <a:prstGeom prst="rect">
+            <a:avLst/>
+          </a:prstGeom>
+          <a:noFill/>
+          <a:ln/>
+        </p:spPr>
+        <p:txBody>
+          <a:bodyPr wrap="square" lIns="0" tIns="0" rIns="0" bIns="0" rtlCol="0" anchor="ctr"/>
+          <a:lstStyle/>
+          <a:p>
+            <a:pPr indent="0" marL="0">
+              <a:buNone/>
+            </a:pPr>
+            <a:r>
+              <a:rPr lang="en-US" sz="1700" dirty="0">
+                <a:solidFill>
+                  <a:srgbClr val="13233F"/>
+                </a:solidFill>
+                <a:latin typeface="Arial" pitchFamily="34" charset="0"/>
+                <a:ea typeface="Arial" pitchFamily="34" charset="-122"/>
+                <a:cs typeface="Arial" pitchFamily="34" charset="-120"/>
+              </a:rPr>
+              <a:t>Can't find the authoritative version</a:t>
+            </a:r>
+            <a:endParaRPr lang="en-US" sz="1700" dirty="0"/>
+          </a:p>
+        </p:txBody>
+      </p:sp>
+      <p:sp>
+        <p:nvSpPr>
+          <p:cNvPr id="24" name="Bullet dot"/>
+          <p:cNvSpPr/>
+          <p:nvPr/>
+        </p:nvSpPr>
+        <p:spPr>
+          <a:xfrm>
+            <a:off x="527037" y="3900488"/>
+            <a:ext cx="88898" cy="88898"/>
+          </a:xfrm>
+          <a:prstGeom prst="ellipse">
+            <a:avLst/>
+          </a:prstGeom>
+          <a:solidFill>
+            <a:srgbClr val="C9A26B"/>
+          </a:solidFill>
+          <a:ln w="12700">
+            <a:solidFill>
+              <a:srgbClr val="C9A26B"/>
+            </a:solidFill>
+            <a:prstDash val="solid"/>
+          </a:ln>
+        </p:spPr>
+      </p:sp>
+      <p:pic>
+        <p:nvPicPr>
+          <p:cNvPr id="25" name="Problem item icon" descr="Problem item icon">    </p:cNvPr>
+          <p:cNvPicPr>
+            <a:picLocks noChangeAspect="1"/>
+          </p:cNvPicPr>
+          <p:nvPr/>
+        </p:nvPicPr>
+        <p:blipFill>
+          <a:blip r:embed="rId7"/>
+          <a:stretch>
+            <a:fillRect/>
+          </a:stretch>
+        </p:blipFill>
+        <p:spPr>
+          <a:xfrm>
+            <a:off x="723882" y="3779246"/>
+            <a:ext cx="317492" cy="317492"/>
+          </a:xfrm>
+          <a:prstGeom prst="rect">
+            <a:avLst/>
+          </a:prstGeom>
+        </p:spPr>
+      </p:pic>
+      <p:sp>
+        <p:nvSpPr>
+          <p:cNvPr id="26" name="Problem item"/>
+          <p:cNvSpPr txBox="1"/>
+          <p:nvPr/>
+        </p:nvSpPr>
+        <p:spPr>
+          <a:xfrm>
+            <a:off x="1257269" y="3798689"/>
+            <a:ext cx="4762381" cy="278606"/>
+          </a:xfrm>
+          <a:prstGeom prst="rect">
+            <a:avLst/>
+          </a:prstGeom>
+          <a:noFill/>
+          <a:ln/>
+        </p:spPr>
+        <p:txBody>
+          <a:bodyPr wrap="square" lIns="0" tIns="0" rIns="0" bIns="0" rtlCol="0" anchor="ctr"/>
+          <a:lstStyle/>
+          <a:p>
+            <a:pPr indent="0" marL="0">
+              <a:buNone/>
+            </a:pPr>
+            <a:r>
+              <a:rPr lang="en-US" sz="1700" dirty="0">
+                <a:solidFill>
+                  <a:srgbClr val="13233F"/>
+                </a:solidFill>
+                <a:latin typeface="Arial" pitchFamily="34" charset="0"/>
+                <a:ea typeface="Arial" pitchFamily="34" charset="-122"/>
+                <a:cs typeface="Arial" pitchFamily="34" charset="-120"/>
+              </a:rPr>
+              <a:t>Hard-to-read legacy format</a:t>
+            </a:r>
+            <a:endParaRPr lang="en-US" sz="1700" dirty="0"/>
+          </a:p>
+        </p:txBody>
+      </p:sp>
+      <p:sp>
+        <p:nvSpPr>
+          <p:cNvPr id="27" name="Bullet dot"/>
+          <p:cNvSpPr/>
+          <p:nvPr/>
+        </p:nvSpPr>
+        <p:spPr>
+          <a:xfrm>
+            <a:off x="527037" y="4302323"/>
+            <a:ext cx="88898" cy="88898"/>
+          </a:xfrm>
+          <a:prstGeom prst="ellipse">
+            <a:avLst/>
+          </a:prstGeom>
+          <a:solidFill>
+            <a:srgbClr val="C9A26B"/>
+          </a:solidFill>
+          <a:ln w="12700">
+            <a:solidFill>
+              <a:srgbClr val="C9A26B"/>
+            </a:solidFill>
+            <a:prstDash val="solid"/>
+          </a:ln>
+        </p:spPr>
+      </p:sp>
+      <p:pic>
+        <p:nvPicPr>
+          <p:cNvPr id="28" name="Problem item icon" descr="Problem item icon">    </p:cNvPr>
+          <p:cNvPicPr>
+            <a:picLocks noChangeAspect="1"/>
+          </p:cNvPicPr>
+          <p:nvPr/>
+        </p:nvPicPr>
+        <p:blipFill>
+          <a:blip r:embed="rId8"/>
+          <a:stretch>
+            <a:fillRect/>
+          </a:stretch>
+        </p:blipFill>
+        <p:spPr>
+          <a:xfrm>
+            <a:off x="723882" y="4181082"/>
+            <a:ext cx="317492" cy="317492"/>
+          </a:xfrm>
+          <a:prstGeom prst="rect">
+            <a:avLst/>
+          </a:prstGeom>
+        </p:spPr>
+      </p:pic>
+      <p:sp>
+        <p:nvSpPr>
+          <p:cNvPr id="29" name="Problem item"/>
+          <p:cNvSpPr txBox="1"/>
+          <p:nvPr/>
+        </p:nvSpPr>
+        <p:spPr>
+          <a:xfrm>
+            <a:off x="1257269" y="4200525"/>
+            <a:ext cx="4762381" cy="278606"/>
+          </a:xfrm>
+          <a:prstGeom prst="rect">
+            <a:avLst/>
+          </a:prstGeom>
+          <a:noFill/>
+          <a:ln/>
+        </p:spPr>
+        <p:txBody>
+          <a:bodyPr wrap="square" lIns="0" tIns="0" rIns="0" bIns="0" rtlCol="0" anchor="ctr"/>
+          <a:lstStyle/>
+          <a:p>
+            <a:pPr indent="0" marL="0">
+              <a:buNone/>
+            </a:pPr>
+            <a:r>
+              <a:rPr lang="en-US" sz="1700" dirty="0">
+                <a:solidFill>
+                  <a:srgbClr val="13233F"/>
+                </a:solidFill>
+                <a:latin typeface="Arial" pitchFamily="34" charset="0"/>
+                <a:ea typeface="Arial" pitchFamily="34" charset="-122"/>
+                <a:cs typeface="Arial" pitchFamily="34" charset="-120"/>
+              </a:rPr>
+              <a:t>Local edits break trust and version control</a:t>
+            </a:r>
+            <a:endParaRPr lang="en-US" sz="1700" dirty="0"/>
+          </a:p>
+        </p:txBody>
+      </p:sp>
+      <p:pic>
+        <p:nvPicPr>
+          <p:cNvPr id="30" name="Fix icon" descr="Fix icon">    </p:cNvPr>
+          <p:cNvPicPr>
+            <a:picLocks noChangeAspect="1"/>
+          </p:cNvPicPr>
+          <p:nvPr/>
+        </p:nvPicPr>
+        <p:blipFill>
+          <a:blip r:embed="rId9"/>
+          <a:stretch>
+            <a:fillRect/>
+          </a:stretch>
+        </p:blipFill>
+        <p:spPr>
+          <a:xfrm>
+            <a:off x="6718132" y="1628775"/>
+            <a:ext cx="419090" cy="419090"/>
+          </a:xfrm>
+          <a:prstGeom prst="rect">
+            <a:avLst/>
+          </a:prstGeom>
+        </p:spPr>
+      </p:pic>
+      <p:sp>
+        <p:nvSpPr>
+          <p:cNvPr id="31" name="Fix heading"/>
+          <p:cNvSpPr txBox="1"/>
+          <p:nvPr/>
+        </p:nvSpPr>
+        <p:spPr>
+          <a:xfrm>
+            <a:off x="7270568" y="1526977"/>
+            <a:ext cx="4444889" cy="589359"/>
+          </a:xfrm>
+          <a:prstGeom prst="rect">
+            <a:avLst/>
+          </a:prstGeom>
+          <a:noFill/>
+          <a:ln/>
+        </p:spPr>
+        <p:txBody>
+          <a:bodyPr wrap="square" lIns="0" tIns="0" rIns="0" bIns="0" rtlCol="0" anchor="ctr"/>
+          <a:lstStyle/>
+          <a:p>
+            <a:pPr indent="0" marL="0">
+              <a:buNone/>
+            </a:pPr>
+            <a:r>
+              <a:rPr lang="en-US" sz="4200" b="1" dirty="0">
+                <a:solidFill>
+                  <a:srgbClr val="0F2341"/>
+                </a:solidFill>
+                <a:latin typeface="Arial" pitchFamily="34" charset="0"/>
+                <a:ea typeface="Arial" pitchFamily="34" charset="-122"/>
+                <a:cs typeface="Arial" pitchFamily="34" charset="-120"/>
+              </a:rPr>
+              <a:t>FIX:</a:t>
+            </a:r>
+            <a:endParaRPr lang="en-US" sz="4200" dirty="0"/>
+          </a:p>
+        </p:txBody>
+      </p:sp>
+      <p:pic>
+        <p:nvPicPr>
+          <p:cNvPr id="32" name="Fix item icon" descr="Fix item icon">    </p:cNvPr>
+          <p:cNvPicPr>
+            <a:picLocks noChangeAspect="1"/>
+          </p:cNvPicPr>
+          <p:nvPr/>
+        </p:nvPicPr>
+        <p:blipFill>
+          <a:blip r:embed="rId10"/>
+          <a:stretch>
+            <a:fillRect/>
+          </a:stretch>
+        </p:blipFill>
+        <p:spPr>
+          <a:xfrm>
+            <a:off x="6743531" y="2145113"/>
+            <a:ext cx="317492" cy="317492"/>
+          </a:xfrm>
+          <a:prstGeom prst="rect">
+            <a:avLst/>
+          </a:prstGeom>
+        </p:spPr>
+      </p:pic>
+      <p:sp>
+        <p:nvSpPr>
+          <p:cNvPr id="33" name="Fix item"/>
+          <p:cNvSpPr txBox="1"/>
+          <p:nvPr/>
+        </p:nvSpPr>
+        <p:spPr>
+          <a:xfrm>
+            <a:off x="7283268" y="2196703"/>
+            <a:ext cx="4825879" cy="214313"/>
+          </a:xfrm>
+          <a:prstGeom prst="rect">
+            <a:avLst/>
+          </a:prstGeom>
+          <a:noFill/>
+          <a:ln/>
+        </p:spPr>
+        <p:txBody>
+          <a:bodyPr wrap="square" lIns="0" tIns="0" rIns="0" bIns="0" rtlCol="0" anchor="ctr"/>
+          <a:lstStyle/>
+          <a:p>
+            <a:pPr indent="0" marL="0">
+              <a:lnSpc>
+                <a:spcPct val="95000"/>
+              </a:lnSpc>
+              <a:buNone/>
+            </a:pPr>
+            <a:r>
+              <a:rPr lang="en-US" sz="1500" dirty="0">
+                <a:solidFill>
+                  <a:srgbClr val="13233F"/>
+                </a:solidFill>
+                <a:latin typeface="Arial" pitchFamily="34" charset="0"/>
+                <a:ea typeface="Arial" pitchFamily="34" charset="-122"/>
+                <a:cs typeface="Arial" pitchFamily="34" charset="-120"/>
+              </a:rPr>
+              <a:t>Local subscriptions for users and roles</a:t>
+            </a:r>
+            <a:endParaRPr lang="en-US" sz="1500" dirty="0"/>
+          </a:p>
+        </p:txBody>
+      </p:sp>
+      <p:pic>
+        <p:nvPicPr>
+          <p:cNvPr id="34" name="Fix item icon" descr="Fix item icon">    </p:cNvPr>
+          <p:cNvPicPr>
+            <a:picLocks noChangeAspect="1"/>
+          </p:cNvPicPr>
+          <p:nvPr/>
+        </p:nvPicPr>
+        <p:blipFill>
+          <a:blip r:embed="rId11"/>
+          <a:stretch>
+            <a:fillRect/>
+          </a:stretch>
+        </p:blipFill>
+        <p:spPr>
+          <a:xfrm>
+            <a:off x="6743531" y="2530876"/>
+            <a:ext cx="317492" cy="317492"/>
+          </a:xfrm>
+          <a:prstGeom prst="rect">
+            <a:avLst/>
+          </a:prstGeom>
+        </p:spPr>
+      </p:pic>
+      <p:sp>
+        <p:nvSpPr>
+          <p:cNvPr id="35" name="Fix item"/>
+          <p:cNvSpPr txBox="1"/>
+          <p:nvPr/>
+        </p:nvSpPr>
+        <p:spPr>
+          <a:xfrm>
+            <a:off x="7283268" y="2582466"/>
+            <a:ext cx="4825879" cy="214313"/>
+          </a:xfrm>
+          <a:prstGeom prst="rect">
+            <a:avLst/>
+          </a:prstGeom>
+          <a:noFill/>
+          <a:ln/>
+        </p:spPr>
+        <p:txBody>
+          <a:bodyPr wrap="square" lIns="0" tIns="0" rIns="0" bIns="0" rtlCol="0" anchor="ctr"/>
+          <a:lstStyle/>
+          <a:p>
+            <a:pPr indent="0" marL="0">
+              <a:lnSpc>
+                <a:spcPct val="95000"/>
+              </a:lnSpc>
+              <a:buNone/>
+            </a:pPr>
+            <a:r>
+              <a:rPr lang="en-US" sz="1500" dirty="0">
+                <a:solidFill>
+                  <a:srgbClr val="13233F"/>
+                </a:solidFill>
+                <a:latin typeface="Arial" pitchFamily="34" charset="0"/>
+                <a:ea typeface="Arial" pitchFamily="34" charset="-122"/>
+                <a:cs typeface="Arial" pitchFamily="34" charset="-120"/>
+              </a:rPr>
+              <a:t>Advanced searches across need to know</a:t>
+            </a:r>
+            <a:endParaRPr lang="en-US" sz="1500" dirty="0"/>
+          </a:p>
+        </p:txBody>
+      </p:sp>
+      <p:pic>
+        <p:nvPicPr>
+          <p:cNvPr id="36" name="Fix item icon" descr="Fix item icon">    </p:cNvPr>
+          <p:cNvPicPr>
+            <a:picLocks noChangeAspect="1"/>
+          </p:cNvPicPr>
+          <p:nvPr/>
+        </p:nvPicPr>
+        <p:blipFill>
+          <a:blip r:embed="rId12"/>
+          <a:stretch>
+            <a:fillRect/>
+          </a:stretch>
+        </p:blipFill>
+        <p:spPr>
+          <a:xfrm>
+            <a:off x="6743531" y="2916638"/>
+            <a:ext cx="317492" cy="317492"/>
+          </a:xfrm>
+          <a:prstGeom prst="rect">
+            <a:avLst/>
+          </a:prstGeom>
+        </p:spPr>
+      </p:pic>
+      <p:sp>
+        <p:nvSpPr>
+          <p:cNvPr id="37" name="Fix item"/>
+          <p:cNvSpPr txBox="1"/>
+          <p:nvPr/>
+        </p:nvSpPr>
+        <p:spPr>
+          <a:xfrm>
+            <a:off x="7283268" y="2968228"/>
+            <a:ext cx="4825879" cy="214313"/>
+          </a:xfrm>
+          <a:prstGeom prst="rect">
+            <a:avLst/>
+          </a:prstGeom>
+          <a:noFill/>
+          <a:ln/>
+        </p:spPr>
+        <p:txBody>
+          <a:bodyPr wrap="square" lIns="0" tIns="0" rIns="0" bIns="0" rtlCol="0" anchor="ctr"/>
+          <a:lstStyle/>
+          <a:p>
+            <a:pPr indent="0" marL="0">
+              <a:lnSpc>
+                <a:spcPct val="95000"/>
+              </a:lnSpc>
+              <a:buNone/>
+            </a:pPr>
+            <a:r>
+              <a:rPr lang="en-US" sz="1500" dirty="0">
+                <a:solidFill>
+                  <a:srgbClr val="13233F"/>
+                </a:solidFill>
+                <a:latin typeface="Arial" pitchFamily="34" charset="0"/>
+                <a:ea typeface="Arial" pitchFamily="34" charset="-122"/>
+                <a:cs typeface="Arial" pitchFamily="34" charset="-120"/>
+              </a:rPr>
+              <a:t>Tailored briefings with mandatory ack and audit</a:t>
+            </a:r>
+            <a:endParaRPr lang="en-US" sz="1500" dirty="0"/>
+          </a:p>
+        </p:txBody>
+      </p:sp>
+      <p:pic>
+        <p:nvPicPr>
+          <p:cNvPr id="38" name="Fix item icon" descr="Fix item icon">    </p:cNvPr>
+          <p:cNvPicPr>
+            <a:picLocks noChangeAspect="1"/>
+          </p:cNvPicPr>
+          <p:nvPr/>
+        </p:nvPicPr>
+        <p:blipFill>
+          <a:blip r:embed="rId13"/>
+          <a:stretch>
+            <a:fillRect/>
+          </a:stretch>
+        </p:blipFill>
+        <p:spPr>
+          <a:xfrm>
+            <a:off x="6743531" y="3302401"/>
+            <a:ext cx="317492" cy="317492"/>
+          </a:xfrm>
+          <a:prstGeom prst="rect">
+            <a:avLst/>
+          </a:prstGeom>
+        </p:spPr>
+      </p:pic>
+      <p:sp>
+        <p:nvSpPr>
+          <p:cNvPr id="39" name="Fix item"/>
+          <p:cNvSpPr txBox="1"/>
+          <p:nvPr/>
+        </p:nvSpPr>
+        <p:spPr>
+          <a:xfrm>
+            <a:off x="7283268" y="3353991"/>
+            <a:ext cx="4825879" cy="214313"/>
+          </a:xfrm>
+          <a:prstGeom prst="rect">
+            <a:avLst/>
+          </a:prstGeom>
+          <a:noFill/>
+          <a:ln/>
+        </p:spPr>
+        <p:txBody>
+          <a:bodyPr wrap="square" lIns="0" tIns="0" rIns="0" bIns="0" rtlCol="0" anchor="ctr"/>
+          <a:lstStyle/>
+          <a:p>
+            <a:pPr indent="0" marL="0">
+              <a:lnSpc>
+                <a:spcPct val="95000"/>
+              </a:lnSpc>
+              <a:buNone/>
+            </a:pPr>
+            <a:r>
+              <a:rPr lang="en-US" sz="1500" dirty="0">
+                <a:solidFill>
+                  <a:srgbClr val="13233F"/>
+                </a:solidFill>
+                <a:latin typeface="Arial" pitchFamily="34" charset="0"/>
+                <a:ea typeface="Arial" pitchFamily="34" charset="-122"/>
+                <a:cs typeface="Arial" pitchFamily="34" charset="-120"/>
+              </a:rPr>
+              <a:t>Offline Mode for EMCON/DDIL</a:t>
+            </a:r>
+            <a:endParaRPr lang="en-US" sz="1500" dirty="0"/>
+          </a:p>
+        </p:txBody>
+      </p:sp>
+      <p:pic>
+        <p:nvPicPr>
+          <p:cNvPr id="40" name="Fix item icon" descr="Fix item icon">    </p:cNvPr>
+          <p:cNvPicPr>
+            <a:picLocks noChangeAspect="1"/>
+          </p:cNvPicPr>
+          <p:nvPr/>
+        </p:nvPicPr>
+        <p:blipFill>
+          <a:blip r:embed="rId14"/>
+          <a:stretch>
+            <a:fillRect/>
+          </a:stretch>
+        </p:blipFill>
+        <p:spPr>
+          <a:xfrm>
+            <a:off x="6743531" y="3688163"/>
+            <a:ext cx="317492" cy="317492"/>
+          </a:xfrm>
+          <a:prstGeom prst="rect">
+            <a:avLst/>
+          </a:prstGeom>
+        </p:spPr>
+      </p:pic>
+      <p:sp>
+        <p:nvSpPr>
+          <p:cNvPr id="41" name="Fix item"/>
+          <p:cNvSpPr txBox="1"/>
+          <p:nvPr/>
+        </p:nvSpPr>
+        <p:spPr>
+          <a:xfrm>
+            <a:off x="7283268" y="3739753"/>
+            <a:ext cx="4825879" cy="214313"/>
+          </a:xfrm>
+          <a:prstGeom prst="rect">
+            <a:avLst/>
+          </a:prstGeom>
+          <a:noFill/>
+          <a:ln/>
+        </p:spPr>
+        <p:txBody>
+          <a:bodyPr wrap="square" lIns="0" tIns="0" rIns="0" bIns="0" rtlCol="0" anchor="ctr"/>
+          <a:lstStyle/>
+          <a:p>
+            <a:pPr indent="0" marL="0">
+              <a:lnSpc>
+                <a:spcPct val="95000"/>
+              </a:lnSpc>
+              <a:buNone/>
+            </a:pPr>
+            <a:r>
+              <a:rPr lang="en-US" sz="1500" dirty="0">
+                <a:solidFill>
+                  <a:srgbClr val="13233F"/>
+                </a:solidFill>
+                <a:latin typeface="Arial" pitchFamily="34" charset="0"/>
+                <a:ea typeface="Arial" pitchFamily="34" charset="-122"/>
+                <a:cs typeface="Arial" pitchFamily="34" charset="-120"/>
+              </a:rPr>
+              <a:t>Encryption - At Rest, In Transit, In Use</a:t>
+            </a:r>
+            <a:endParaRPr lang="en-US" sz="1500" dirty="0"/>
+          </a:p>
+        </p:txBody>
+      </p:sp>
+      <p:pic>
+        <p:nvPicPr>
+          <p:cNvPr id="42" name="Fix item icon" descr="Fix item icon">    </p:cNvPr>
+          <p:cNvPicPr>
+            <a:picLocks noChangeAspect="1"/>
+          </p:cNvPicPr>
+          <p:nvPr/>
+        </p:nvPicPr>
+        <p:blipFill>
+          <a:blip r:embed="rId15"/>
+          <a:stretch>
+            <a:fillRect/>
+          </a:stretch>
+        </p:blipFill>
+        <p:spPr>
+          <a:xfrm>
+            <a:off x="6743531" y="4138220"/>
+            <a:ext cx="317492" cy="317492"/>
+          </a:xfrm>
+          <a:prstGeom prst="rect">
+            <a:avLst/>
+          </a:prstGeom>
+        </p:spPr>
+      </p:pic>
+      <p:sp>
+        <p:nvSpPr>
+          <p:cNvPr id="43" name="Fix item"/>
+          <p:cNvSpPr txBox="1"/>
+          <p:nvPr/>
+        </p:nvSpPr>
+        <p:spPr>
+          <a:xfrm>
+            <a:off x="7283268" y="4082653"/>
+            <a:ext cx="4825879" cy="428625"/>
+          </a:xfrm>
+          <a:prstGeom prst="rect">
+            <a:avLst/>
+          </a:prstGeom>
+          <a:noFill/>
+          <a:ln/>
+        </p:spPr>
+        <p:txBody>
+          <a:bodyPr wrap="square" lIns="0" tIns="0" rIns="0" bIns="0" rtlCol="0" anchor="ctr"/>
+          <a:lstStyle/>
+          <a:p>
+            <a:pPr indent="0" marL="0">
+              <a:lnSpc>
+                <a:spcPct val="95000"/>
+              </a:lnSpc>
+              <a:buNone/>
+            </a:pPr>
+            <a:r>
+              <a:rPr lang="en-US" sz="1500" dirty="0">
+                <a:solidFill>
+                  <a:srgbClr val="13233F"/>
+                </a:solidFill>
+                <a:latin typeface="Arial" pitchFamily="34" charset="0"/>
+                <a:ea typeface="Arial" pitchFamily="34" charset="-122"/>
+                <a:cs typeface="Arial" pitchFamily="34" charset="-120"/>
+              </a:rPr>
+              <a:t>Secure by Design -</a:t>
+            </a:r>
+            <a:endParaRPr lang="en-US" sz="1500" dirty="0"/>
+          </a:p>
+          <a:p>
+            <a:pPr indent="0" marL="0">
+              <a:lnSpc>
+                <a:spcPct val="95000"/>
+              </a:lnSpc>
+              <a:buNone/>
+            </a:pPr>
+            <a:r>
+              <a:rPr lang="en-US" sz="1500" dirty="0">
+                <a:solidFill>
+                  <a:srgbClr val="13233F"/>
+                </a:solidFill>
+                <a:latin typeface="Arial" pitchFamily="34" charset="0"/>
+                <a:ea typeface="Arial" pitchFamily="34" charset="-122"/>
+                <a:cs typeface="Arial" pitchFamily="34" charset="-120"/>
+              </a:rPr>
+              <a:t>Confidentiality, Integrity, Availability</a:t>
+            </a:r>
+            <a:endParaRPr lang="en-US" sz="1500" dirty="0"/>
+          </a:p>
+        </p:txBody>
+      </p:sp>
+      <p:sp>
+        <p:nvSpPr>
+          <p:cNvPr id="44" name="Impact band"/>
+          <p:cNvSpPr/>
+          <p:nvPr/>
+        </p:nvSpPr>
+        <p:spPr>
+          <a:xfrm>
+            <a:off x="0" y="4741664"/>
+            <a:ext cx="12191695" cy="1714500"/>
+          </a:xfrm>
+          <a:prstGeom prst="rect">
+            <a:avLst/>
+          </a:prstGeom>
+          <a:solidFill>
+            <a:srgbClr val="CBAA7A"/>
+          </a:solidFill>
+          <a:ln w="12700">
+            <a:solidFill>
+              <a:srgbClr val="CBAA7A"/>
+            </a:solidFill>
+            <a:prstDash val="solid"/>
+          </a:ln>
+        </p:spPr>
+      </p:sp>
+      <p:sp>
+        <p:nvSpPr>
+          <p:cNvPr id="45" name="Impact heading"/>
+          <p:cNvSpPr txBox="1"/>
+          <p:nvPr/>
+        </p:nvSpPr>
+        <p:spPr>
+          <a:xfrm>
+            <a:off x="2285943" y="4811316"/>
+            <a:ext cx="7619810" cy="332184"/>
+          </a:xfrm>
+          <a:prstGeom prst="rect">
+            <a:avLst/>
+          </a:prstGeom>
+          <a:noFill/>
+          <a:ln/>
+        </p:spPr>
+        <p:txBody>
+          <a:bodyPr wrap="square" lIns="0" tIns="0" rIns="0" bIns="0" rtlCol="0" anchor="ctr"/>
+          <a:lstStyle/>
+          <a:p>
+            <a:pPr algn="ctr" indent="0" marL="0">
+              <a:buNone/>
+            </a:pPr>
+            <a:r>
+              <a:rPr lang="en-US" sz="2200" b="1" dirty="0">
+                <a:solidFill>
+                  <a:srgbClr val="0F2341"/>
+                </a:solidFill>
+                <a:latin typeface="Arial" pitchFamily="34" charset="0"/>
+                <a:ea typeface="Arial" pitchFamily="34" charset="-122"/>
+                <a:cs typeface="Arial" pitchFamily="34" charset="-120"/>
+              </a:rPr>
+              <a:t>Warfighting Impact &amp; Fleet Readiness</a:t>
+            </a:r>
+            <a:endParaRPr lang="en-US" sz="2200" dirty="0"/>
+          </a:p>
+        </p:txBody>
+      </p:sp>
+      <p:sp>
+        <p:nvSpPr>
+          <p:cNvPr id="46" name="Shape 29"/>
+          <p:cNvSpPr/>
+          <p:nvPr/>
+        </p:nvSpPr>
+        <p:spPr>
+          <a:xfrm>
+            <a:off x="4190895" y="5331023"/>
+            <a:ext cx="0" cy="910828"/>
+          </a:xfrm>
+          <a:prstGeom prst="line">
+            <a:avLst/>
+          </a:prstGeom>
+          <a:noFill/>
+          <a:ln w="12700">
+            <a:solidFill>
+              <a:srgbClr val="A68A60"/>
+            </a:solidFill>
+            <a:prstDash val="solid"/>
+          </a:ln>
+        </p:spPr>
+      </p:sp>
+      <p:sp>
+        <p:nvSpPr>
+          <p:cNvPr id="47" name="Shape 30"/>
+          <p:cNvSpPr/>
+          <p:nvPr/>
+        </p:nvSpPr>
+        <p:spPr>
+          <a:xfrm>
+            <a:off x="8045249" y="5331023"/>
+            <a:ext cx="0" cy="910828"/>
+          </a:xfrm>
+          <a:prstGeom prst="line">
+            <a:avLst/>
+          </a:prstGeom>
+          <a:noFill/>
+          <a:ln w="12700">
+            <a:solidFill>
+              <a:srgbClr val="A68A60"/>
+            </a:solidFill>
+            <a:prstDash val="solid"/>
+          </a:ln>
+        </p:spPr>
+      </p:sp>
+      <p:pic>
+        <p:nvPicPr>
+          <p:cNvPr id="48" name="Speed icon" descr="Speed icon">    </p:cNvPr>
+          <p:cNvPicPr>
+            <a:picLocks noChangeAspect="1"/>
+          </p:cNvPicPr>
+          <p:nvPr/>
+        </p:nvPicPr>
+        <p:blipFill>
+          <a:blip r:embed="rId16"/>
+          <a:stretch>
+            <a:fillRect/>
+          </a:stretch>
+        </p:blipFill>
+        <p:spPr>
+          <a:xfrm>
+            <a:off x="1904952" y="5154216"/>
+            <a:ext cx="419090" cy="419090"/>
+          </a:xfrm>
+          <a:prstGeom prst="rect">
+            <a:avLst/>
+          </a:prstGeom>
+        </p:spPr>
+      </p:pic>
+      <p:sp>
+        <p:nvSpPr>
+          <p:cNvPr id="49" name="Impact 1 headline"/>
+          <p:cNvSpPr txBox="1"/>
+          <p:nvPr/>
+        </p:nvSpPr>
+        <p:spPr>
+          <a:xfrm>
+            <a:off x="253994" y="5636419"/>
+            <a:ext cx="3809905" cy="278606"/>
+          </a:xfrm>
+          <a:prstGeom prst="rect">
+            <a:avLst/>
+          </a:prstGeom>
+          <a:noFill/>
+          <a:ln/>
+        </p:spPr>
+        <p:txBody>
+          <a:bodyPr wrap="square" lIns="0" tIns="0" rIns="0" bIns="0" rtlCol="0" anchor="ctr"/>
+          <a:lstStyle/>
+          <a:p>
+            <a:pPr algn="ctr" indent="0" marL="0">
+              <a:buNone/>
+            </a:pPr>
+            <a:r>
+              <a:rPr lang="en-US" sz="1800" b="1" dirty="0">
+                <a:solidFill>
+                  <a:srgbClr val="0F2341"/>
+                </a:solidFill>
+                <a:latin typeface="Arial" pitchFamily="34" charset="0"/>
+                <a:ea typeface="Arial" pitchFamily="34" charset="-122"/>
+                <a:cs typeface="Arial" pitchFamily="34" charset="-120"/>
+              </a:rPr>
+              <a:t>Faster time to actionable delivery</a:t>
+            </a:r>
+            <a:endParaRPr lang="en-US" sz="1800" dirty="0"/>
+          </a:p>
+        </p:txBody>
+      </p:sp>
+      <p:sp>
+        <p:nvSpPr>
+          <p:cNvPr id="50" name="Impact 1 detail"/>
+          <p:cNvSpPr txBox="1"/>
+          <p:nvPr/>
+        </p:nvSpPr>
+        <p:spPr>
+          <a:xfrm>
+            <a:off x="253994" y="5925741"/>
+            <a:ext cx="3809905" cy="375047"/>
+          </a:xfrm>
+          <a:prstGeom prst="rect">
+            <a:avLst/>
+          </a:prstGeom>
+          <a:noFill/>
+          <a:ln/>
+        </p:spPr>
+        <p:txBody>
+          <a:bodyPr wrap="square" lIns="0" tIns="0" rIns="0" bIns="0" rtlCol="0" anchor="ctr"/>
+          <a:lstStyle/>
+          <a:p>
+            <a:pPr algn="ctr" indent="0" marL="0">
+              <a:buNone/>
+            </a:pPr>
+            <a:r>
+              <a:rPr lang="en-US" sz="1250" dirty="0">
+                <a:solidFill>
+                  <a:srgbClr val="13233F"/>
+                </a:solidFill>
+                <a:latin typeface="Arial" pitchFamily="34" charset="0"/>
+                <a:ea typeface="Arial" pitchFamily="34" charset="-122"/>
+                <a:cs typeface="Arial" pitchFamily="34" charset="-120"/>
+              </a:rPr>
+              <a:t>Time saved for the mission —</a:t>
+            </a:r>
+            <a:endParaRPr lang="en-US" sz="1250" dirty="0"/>
+          </a:p>
+          <a:p>
+            <a:pPr algn="ctr" indent="0" marL="0">
+              <a:buNone/>
+            </a:pPr>
+            <a:r>
+              <a:rPr lang="en-US" sz="1250" dirty="0">
+                <a:solidFill>
+                  <a:srgbClr val="13233F"/>
+                </a:solidFill>
+                <a:latin typeface="Arial" pitchFamily="34" charset="0"/>
+                <a:ea typeface="Arial" pitchFamily="34" charset="-122"/>
+                <a:cs typeface="Arial" pitchFamily="34" charset="-120"/>
+              </a:rPr>
+              <a:t>not inbox management</a:t>
+            </a:r>
+            <a:endParaRPr lang="en-US" sz="1250" dirty="0"/>
+          </a:p>
+        </p:txBody>
+      </p:sp>
+      <p:pic>
+        <p:nvPicPr>
+          <p:cNvPr id="51" name="Satellite icon" descr="Satellite icon">    </p:cNvPr>
+          <p:cNvPicPr>
+            <a:picLocks noChangeAspect="1"/>
+          </p:cNvPicPr>
+          <p:nvPr/>
+        </p:nvPicPr>
+        <p:blipFill>
+          <a:blip r:embed="rId17"/>
+          <a:stretch>
+            <a:fillRect/>
+          </a:stretch>
+        </p:blipFill>
+        <p:spPr>
+          <a:xfrm>
+            <a:off x="5905352" y="5154216"/>
+            <a:ext cx="419090" cy="419090"/>
+          </a:xfrm>
+          <a:prstGeom prst="rect">
+            <a:avLst/>
+          </a:prstGeom>
+        </p:spPr>
+      </p:pic>
+      <p:sp>
+        <p:nvSpPr>
+          <p:cNvPr id="52" name="Impact 2 headline"/>
+          <p:cNvSpPr txBox="1"/>
+          <p:nvPr/>
+        </p:nvSpPr>
+        <p:spPr>
+          <a:xfrm>
+            <a:off x="4317892" y="5625703"/>
+            <a:ext cx="3619410" cy="492919"/>
+          </a:xfrm>
+          <a:prstGeom prst="rect">
+            <a:avLst/>
+          </a:prstGeom>
+          <a:noFill/>
+          <a:ln/>
+        </p:spPr>
+        <p:txBody>
+          <a:bodyPr wrap="square" lIns="0" tIns="0" rIns="0" bIns="0" rtlCol="0" anchor="ctr"/>
+          <a:lstStyle/>
+          <a:p>
+            <a:pPr algn="ctr" indent="0" marL="0">
+              <a:lnSpc>
+                <a:spcPct val="95000"/>
+              </a:lnSpc>
+              <a:buNone/>
+            </a:pPr>
+            <a:r>
+              <a:rPr lang="en-US" sz="1800" b="1" dirty="0">
+                <a:solidFill>
+                  <a:srgbClr val="0F2341"/>
+                </a:solidFill>
+                <a:latin typeface="Arial" pitchFamily="34" charset="0"/>
+                <a:ea typeface="Arial" pitchFamily="34" charset="-122"/>
+                <a:cs typeface="Arial" pitchFamily="34" charset="-120"/>
+              </a:rPr>
+              <a:t>Speed to Fleet</a:t>
+            </a:r>
+            <a:endParaRPr lang="en-US" sz="1800" dirty="0"/>
+          </a:p>
+          <a:p>
+            <a:pPr algn="ctr" indent="0" marL="0">
+              <a:lnSpc>
+                <a:spcPct val="95000"/>
+              </a:lnSpc>
+              <a:buNone/>
+            </a:pPr>
+            <a:r>
+              <a:rPr lang="en-US" sz="1800" b="1" dirty="0">
+                <a:solidFill>
+                  <a:srgbClr val="0F2341"/>
+                </a:solidFill>
+                <a:latin typeface="Arial" pitchFamily="34" charset="0"/>
+                <a:ea typeface="Arial" pitchFamily="34" charset="-122"/>
+                <a:cs typeface="Arial" pitchFamily="34" charset="-120"/>
+              </a:rPr>
+              <a:t>DDIL capable</a:t>
+            </a:r>
+            <a:endParaRPr lang="en-US" sz="1800" dirty="0"/>
+          </a:p>
+        </p:txBody>
+      </p:sp>
+      <p:sp>
+        <p:nvSpPr>
+          <p:cNvPr id="53" name="Impact 2 detail"/>
+          <p:cNvSpPr txBox="1"/>
+          <p:nvPr/>
+        </p:nvSpPr>
+        <p:spPr>
+          <a:xfrm>
+            <a:off x="4317892" y="6140053"/>
+            <a:ext cx="3619410" cy="214313"/>
+          </a:xfrm>
+          <a:prstGeom prst="rect">
+            <a:avLst/>
+          </a:prstGeom>
+          <a:noFill/>
+          <a:ln/>
+        </p:spPr>
+        <p:txBody>
+          <a:bodyPr wrap="square" lIns="0" tIns="0" rIns="0" bIns="0" rtlCol="0" anchor="ctr"/>
+          <a:lstStyle/>
+          <a:p>
+            <a:pPr algn="ctr" indent="0" marL="0">
+              <a:buNone/>
+            </a:pPr>
+            <a:r>
+              <a:rPr lang="en-US" sz="1300" dirty="0">
+                <a:solidFill>
+                  <a:srgbClr val="13233F"/>
+                </a:solidFill>
+                <a:latin typeface="Arial" pitchFamily="34" charset="0"/>
+                <a:ea typeface="Arial" pitchFamily="34" charset="-122"/>
+                <a:cs typeface="Arial" pitchFamily="34" charset="-120"/>
+              </a:rPr>
+              <a:t>Operates offline · low-bandwidth resilient</a:t>
+            </a:r>
+            <a:endParaRPr lang="en-US" sz="1300" dirty="0"/>
+          </a:p>
+        </p:txBody>
+      </p:sp>
+      <p:pic>
+        <p:nvPicPr>
+          <p:cNvPr id="54" name="Network icon" descr="Network icon">    </p:cNvPr>
+          <p:cNvPicPr>
+            <a:picLocks noChangeAspect="1"/>
+          </p:cNvPicPr>
+          <p:nvPr/>
+        </p:nvPicPr>
+        <p:blipFill>
+          <a:blip r:embed="rId18"/>
+          <a:stretch>
+            <a:fillRect/>
+          </a:stretch>
+        </p:blipFill>
+        <p:spPr>
+          <a:xfrm>
+            <a:off x="9823204" y="5154216"/>
+            <a:ext cx="419090" cy="419090"/>
+          </a:xfrm>
+          <a:prstGeom prst="rect">
+            <a:avLst/>
+          </a:prstGeom>
+        </p:spPr>
+      </p:pic>
+      <p:sp>
+        <p:nvSpPr>
+          <p:cNvPr id="55" name="Impact 3 headline"/>
+          <p:cNvSpPr txBox="1"/>
+          <p:nvPr/>
+        </p:nvSpPr>
+        <p:spPr>
+          <a:xfrm>
+            <a:off x="8191295" y="5625703"/>
+            <a:ext cx="3682908" cy="492919"/>
+          </a:xfrm>
+          <a:prstGeom prst="rect">
+            <a:avLst/>
+          </a:prstGeom>
+          <a:noFill/>
+          <a:ln/>
+        </p:spPr>
+        <p:txBody>
+          <a:bodyPr wrap="square" lIns="0" tIns="0" rIns="0" bIns="0" rtlCol="0" anchor="ctr"/>
+          <a:lstStyle/>
+          <a:p>
+            <a:pPr algn="ctr" indent="0" marL="0">
+              <a:lnSpc>
+                <a:spcPct val="95000"/>
+              </a:lnSpc>
+              <a:buNone/>
+            </a:pPr>
+            <a:r>
+              <a:rPr lang="en-US" sz="1800" b="1" dirty="0">
+                <a:solidFill>
+                  <a:srgbClr val="0F2341"/>
+                </a:solidFill>
+                <a:latin typeface="Arial" pitchFamily="34" charset="0"/>
+                <a:ea typeface="Arial" pitchFamily="34" charset="-122"/>
+                <a:cs typeface="Arial" pitchFamily="34" charset="-120"/>
+              </a:rPr>
+              <a:t>SCALABLE</a:t>
+            </a:r>
+            <a:endParaRPr lang="en-US" sz="1800" dirty="0"/>
+          </a:p>
+        </p:txBody>
+      </p:sp>
+      <p:sp>
+        <p:nvSpPr>
+          <p:cNvPr id="56" name="Impact 3 detail"/>
+          <p:cNvSpPr txBox="1"/>
+          <p:nvPr/>
+        </p:nvSpPr>
+        <p:spPr>
+          <a:xfrm>
+            <a:off x="8191295" y="6140053"/>
+            <a:ext cx="3682908" cy="214313"/>
+          </a:xfrm>
+          <a:prstGeom prst="rect">
+            <a:avLst/>
+          </a:prstGeom>
+          <a:noFill/>
+          <a:ln/>
+        </p:spPr>
+        <p:txBody>
+          <a:bodyPr wrap="square" lIns="0" tIns="0" rIns="0" bIns="0" rtlCol="0" anchor="ctr"/>
+          <a:lstStyle/>
+          <a:p>
+            <a:pPr algn="ctr" indent="0" marL="0">
+              <a:buNone/>
+            </a:pPr>
+            <a:r>
+              <a:rPr lang="en-US" sz="1300" dirty="0">
+                <a:solidFill>
+                  <a:srgbClr val="13233F"/>
+                </a:solidFill>
+                <a:latin typeface="Arial" pitchFamily="34" charset="0"/>
+                <a:ea typeface="Arial" pitchFamily="34" charset="-122"/>
+                <a:cs typeface="Arial" pitchFamily="34" charset="-120"/>
+              </a:rPr>
+              <a:t>All Service · All Domains</a:t>
+            </a:r>
+            <a:endParaRPr lang="en-US" sz="1300" dirty="0"/>
+          </a:p>
+        </p:txBody>
+      </p:sp>
+      <p:sp>
+        <p:nvSpPr>
+          <p:cNvPr id="57" name="Footer band"/>
+          <p:cNvSpPr/>
+          <p:nvPr/>
+        </p:nvSpPr>
+        <p:spPr>
+          <a:xfrm>
+            <a:off x="0" y="6456164"/>
+            <a:ext cx="12191695" cy="401836"/>
+          </a:xfrm>
+          <a:prstGeom prst="rect">
+            <a:avLst/>
+          </a:prstGeom>
+          <a:solidFill>
+            <a:srgbClr val="0F2341"/>
+          </a:solidFill>
+          <a:ln w="12700">
+            <a:solidFill>
+              <a:srgbClr val="0F2341"/>
+            </a:solidFill>
+            <a:prstDash val="solid"/>
+          </a:ln>
+        </p:spPr>
+      </p:sp>
+      <p:sp>
+        <p:nvSpPr>
+          <p:cNvPr id="58" name="Footer"/>
+          <p:cNvSpPr txBox="1"/>
+          <p:nvPr/>
+        </p:nvSpPr>
+        <p:spPr>
+          <a:xfrm>
+            <a:off x="253994" y="6493669"/>
+            <a:ext cx="11683708" cy="332184"/>
+          </a:xfrm>
+          <a:prstGeom prst="rect">
+            <a:avLst/>
+          </a:prstGeom>
+          <a:noFill/>
+          <a:ln/>
+        </p:spPr>
+        <p:txBody>
+          <a:bodyPr wrap="square" lIns="0" tIns="0" rIns="0" bIns="0" rtlCol="0" anchor="ctr"/>
+          <a:lstStyle/>
+          <a:p>
+            <a:pPr algn="ctr" indent="0" marL="0">
+              <a:buNone/>
+            </a:pPr>
+            <a:r>
+              <a:rPr lang="en-US" sz="1300" b="1" spc="350" kern="0" dirty="0">
+                <a:solidFill>
+                  <a:srgbClr val="D9BC8C"/>
+                </a:solidFill>
+                <a:latin typeface="Arial" pitchFamily="34" charset="0"/>
+                <a:ea typeface="Arial" pitchFamily="34" charset="-122"/>
+                <a:cs typeface="Arial" pitchFamily="34" charset="-120"/>
+              </a:rPr>
+              <a:t>ANCHOR  •  Secure  •  Auditable  •  Interoperable  •  Department of War  •  Wide Ready</a:t>
+            </a:r>
+            <a:endParaRPr lang="en-US" sz="1300" dirty="0"/>
+          </a:p>
+        </p:txBody>
+      </p:sp>
+    </p:spTree>
+  </p:cSld>
+  <p:clrMapOvr>
+    <a:masterClrMapping/>
+  </p:clrMapOvr>
+</p:sld>
+</file>
+
 <file path=ppt/theme/theme1.xml><?xml version="1.0" encoding="utf-8"?>
 <a:theme xmlns:a="http://schemas.openxmlformats.org/drawingml/2006/main" name="Office Theme">
   <a:themeElements>

</xml_diff>